<commit_message>
update du fichier pptx non fait + ajout fichier pdf
</commit_message>
<xml_diff>
--- a/Schéma_elec_alternateur.pptx
+++ b/Schéma_elec_alternateur.pptx
@@ -11,6 +11,8 @@
     <p:sldId id="261" r:id="rId5"/>
     <p:sldId id="259" r:id="rId6"/>
     <p:sldId id="262" r:id="rId7"/>
+    <p:sldId id="263" r:id="rId8"/>
+    <p:sldId id="264" r:id="rId9"/>
   </p:sldIdLst>
   <p:sldSz cx="12192000" cy="6858000"/>
   <p:notesSz cx="6858000" cy="9144000"/>
@@ -264,7 +266,7 @@
           <a:p>
             <a:fld id="{D121BB91-A7E4-49BF-8EAA-5A539C67AE34}" type="datetimeFigureOut">
               <a:rPr lang="fr-FR" smtClean="0"/>
-              <a:t>21/06/2025</a:t>
+              <a:t>02/07/2025</a:t>
             </a:fld>
             <a:endParaRPr lang="fr-FR"/>
           </a:p>
@@ -462,7 +464,7 @@
           <a:p>
             <a:fld id="{D121BB91-A7E4-49BF-8EAA-5A539C67AE34}" type="datetimeFigureOut">
               <a:rPr lang="fr-FR" smtClean="0"/>
-              <a:t>21/06/2025</a:t>
+              <a:t>02/07/2025</a:t>
             </a:fld>
             <a:endParaRPr lang="fr-FR"/>
           </a:p>
@@ -670,7 +672,7 @@
           <a:p>
             <a:fld id="{D121BB91-A7E4-49BF-8EAA-5A539C67AE34}" type="datetimeFigureOut">
               <a:rPr lang="fr-FR" smtClean="0"/>
-              <a:t>21/06/2025</a:t>
+              <a:t>02/07/2025</a:t>
             </a:fld>
             <a:endParaRPr lang="fr-FR"/>
           </a:p>
@@ -868,7 +870,7 @@
           <a:p>
             <a:fld id="{D121BB91-A7E4-49BF-8EAA-5A539C67AE34}" type="datetimeFigureOut">
               <a:rPr lang="fr-FR" smtClean="0"/>
-              <a:t>21/06/2025</a:t>
+              <a:t>02/07/2025</a:t>
             </a:fld>
             <a:endParaRPr lang="fr-FR"/>
           </a:p>
@@ -1143,7 +1145,7 @@
           <a:p>
             <a:fld id="{D121BB91-A7E4-49BF-8EAA-5A539C67AE34}" type="datetimeFigureOut">
               <a:rPr lang="fr-FR" smtClean="0"/>
-              <a:t>21/06/2025</a:t>
+              <a:t>02/07/2025</a:t>
             </a:fld>
             <a:endParaRPr lang="fr-FR"/>
           </a:p>
@@ -1408,7 +1410,7 @@
           <a:p>
             <a:fld id="{D121BB91-A7E4-49BF-8EAA-5A539C67AE34}" type="datetimeFigureOut">
               <a:rPr lang="fr-FR" smtClean="0"/>
-              <a:t>21/06/2025</a:t>
+              <a:t>02/07/2025</a:t>
             </a:fld>
             <a:endParaRPr lang="fr-FR"/>
           </a:p>
@@ -1820,7 +1822,7 @@
           <a:p>
             <a:fld id="{D121BB91-A7E4-49BF-8EAA-5A539C67AE34}" type="datetimeFigureOut">
               <a:rPr lang="fr-FR" smtClean="0"/>
-              <a:t>21/06/2025</a:t>
+              <a:t>02/07/2025</a:t>
             </a:fld>
             <a:endParaRPr lang="fr-FR"/>
           </a:p>
@@ -1961,7 +1963,7 @@
           <a:p>
             <a:fld id="{D121BB91-A7E4-49BF-8EAA-5A539C67AE34}" type="datetimeFigureOut">
               <a:rPr lang="fr-FR" smtClean="0"/>
-              <a:t>21/06/2025</a:t>
+              <a:t>02/07/2025</a:t>
             </a:fld>
             <a:endParaRPr lang="fr-FR"/>
           </a:p>
@@ -2074,7 +2076,7 @@
           <a:p>
             <a:fld id="{D121BB91-A7E4-49BF-8EAA-5A539C67AE34}" type="datetimeFigureOut">
               <a:rPr lang="fr-FR" smtClean="0"/>
-              <a:t>21/06/2025</a:t>
+              <a:t>02/07/2025</a:t>
             </a:fld>
             <a:endParaRPr lang="fr-FR"/>
           </a:p>
@@ -2385,7 +2387,7 @@
           <a:p>
             <a:fld id="{D121BB91-A7E4-49BF-8EAA-5A539C67AE34}" type="datetimeFigureOut">
               <a:rPr lang="fr-FR" smtClean="0"/>
-              <a:t>21/06/2025</a:t>
+              <a:t>02/07/2025</a:t>
             </a:fld>
             <a:endParaRPr lang="fr-FR"/>
           </a:p>
@@ -2673,7 +2675,7 @@
           <a:p>
             <a:fld id="{D121BB91-A7E4-49BF-8EAA-5A539C67AE34}" type="datetimeFigureOut">
               <a:rPr lang="fr-FR" smtClean="0"/>
-              <a:t>21/06/2025</a:t>
+              <a:t>02/07/2025</a:t>
             </a:fld>
             <a:endParaRPr lang="fr-FR"/>
           </a:p>
@@ -2914,7 +2916,7 @@
           <a:p>
             <a:fld id="{D121BB91-A7E4-49BF-8EAA-5A539C67AE34}" type="datetimeFigureOut">
               <a:rPr lang="fr-FR" smtClean="0"/>
-              <a:t>21/06/2025</a:t>
+              <a:t>02/07/2025</a:t>
             </a:fld>
             <a:endParaRPr lang="fr-FR"/>
           </a:p>
@@ -5015,7 +5017,7 @@
         </p:nvGrpSpPr>
         <p:grpSpPr>
           <a:xfrm>
-            <a:off x="6512558" y="474384"/>
+            <a:off x="6366254" y="474384"/>
             <a:ext cx="5679442" cy="5261253"/>
             <a:chOff x="3332480" y="616903"/>
             <a:chExt cx="5679442" cy="5261253"/>
@@ -6215,6 +6217,907 @@
 </p:sld>
 </file>
 
+<file path=ppt/slides/slide7.xml><?xml version="1.0" encoding="utf-8"?>
+<p:sld xmlns:a="http://schemas.openxmlformats.org/drawingml/2006/main" xmlns:r="http://schemas.openxmlformats.org/officeDocument/2006/relationships" xmlns:p="http://schemas.openxmlformats.org/presentationml/2006/main">
+  <p:cSld>
+    <p:spTree>
+      <p:nvGrpSpPr>
+        <p:cNvPr id="1" name=""/>
+        <p:cNvGrpSpPr/>
+        <p:nvPr/>
+      </p:nvGrpSpPr>
+      <p:grpSpPr>
+        <a:xfrm>
+          <a:off x="0" y="0"/>
+          <a:ext cx="0" cy="0"/>
+          <a:chOff x="0" y="0"/>
+          <a:chExt cx="0" cy="0"/>
+        </a:xfrm>
+      </p:grpSpPr>
+      <p:pic>
+        <p:nvPicPr>
+          <p:cNvPr id="1026" name="Picture 2" descr="Couplage d'un moteur asynchrone triphasé">
+            <a:extLst>
+              <a:ext uri="{FF2B5EF4-FFF2-40B4-BE49-F238E27FC236}">
+                <a16:creationId xmlns:a16="http://schemas.microsoft.com/office/drawing/2014/main" id="{32828BA1-0E76-06E6-5A86-AD5AE050F281}"/>
+              </a:ext>
+            </a:extLst>
+          </p:cNvPr>
+          <p:cNvPicPr>
+            <a:picLocks noChangeAspect="1" noChangeArrowheads="1"/>
+          </p:cNvPicPr>
+          <p:nvPr/>
+        </p:nvPicPr>
+        <p:blipFill>
+          <a:blip r:embed="rId2">
+            <a:extLst>
+              <a:ext uri="{28A0092B-C50C-407E-A947-70E740481C1C}">
+                <a14:useLocalDpi xmlns:a14="http://schemas.microsoft.com/office/drawing/2010/main" val="0"/>
+              </a:ext>
+            </a:extLst>
+          </a:blip>
+          <a:srcRect/>
+          <a:stretch>
+            <a:fillRect/>
+          </a:stretch>
+        </p:blipFill>
+        <p:spPr bwMode="auto">
+          <a:xfrm>
+            <a:off x="952500" y="0"/>
+            <a:ext cx="10287000" cy="6858000"/>
+          </a:xfrm>
+          <a:prstGeom prst="rect">
+            <a:avLst/>
+          </a:prstGeom>
+          <a:noFill/>
+          <a:extLst>
+            <a:ext uri="{909E8E84-426E-40DD-AFC4-6F175D3DCCD1}">
+              <a14:hiddenFill xmlns:a14="http://schemas.microsoft.com/office/drawing/2010/main">
+                <a:solidFill>
+                  <a:srgbClr val="FFFFFF"/>
+                </a:solidFill>
+              </a14:hiddenFill>
+            </a:ext>
+          </a:extLst>
+        </p:spPr>
+      </p:pic>
+    </p:spTree>
+    <p:extLst>
+      <p:ext uri="{BB962C8B-B14F-4D97-AF65-F5344CB8AC3E}">
+        <p14:creationId xmlns:p14="http://schemas.microsoft.com/office/powerpoint/2010/main" val="3075458997"/>
+      </p:ext>
+    </p:extLst>
+  </p:cSld>
+  <p:clrMapOvr>
+    <a:masterClrMapping/>
+  </p:clrMapOvr>
+</p:sld>
+</file>
+
+<file path=ppt/slides/slide8.xml><?xml version="1.0" encoding="utf-8"?>
+<p:sld xmlns:a="http://schemas.openxmlformats.org/drawingml/2006/main" xmlns:r="http://schemas.openxmlformats.org/officeDocument/2006/relationships" xmlns:p="http://schemas.openxmlformats.org/presentationml/2006/main">
+  <p:cSld>
+    <p:spTree>
+      <p:nvGrpSpPr>
+        <p:cNvPr id="1" name="">
+          <a:extLst>
+            <a:ext uri="{FF2B5EF4-FFF2-40B4-BE49-F238E27FC236}">
+              <a16:creationId xmlns:a16="http://schemas.microsoft.com/office/drawing/2014/main" id="{7C293FE9-3F2F-475A-62D3-7B2BD49D2346}"/>
+            </a:ext>
+          </a:extLst>
+        </p:cNvPr>
+        <p:cNvGrpSpPr/>
+        <p:nvPr/>
+      </p:nvGrpSpPr>
+      <p:grpSpPr>
+        <a:xfrm>
+          <a:off x="0" y="0"/>
+          <a:ext cx="0" cy="0"/>
+          <a:chOff x="0" y="0"/>
+          <a:chExt cx="0" cy="0"/>
+        </a:xfrm>
+      </p:grpSpPr>
+      <p:pic>
+        <p:nvPicPr>
+          <p:cNvPr id="1026" name="Picture 2" descr="Couplage d'un moteur asynchrone triphasé">
+            <a:extLst>
+              <a:ext uri="{FF2B5EF4-FFF2-40B4-BE49-F238E27FC236}">
+                <a16:creationId xmlns:a16="http://schemas.microsoft.com/office/drawing/2014/main" id="{D96C6082-3251-A3D9-EC05-F0D8248C6333}"/>
+              </a:ext>
+            </a:extLst>
+          </p:cNvPr>
+          <p:cNvPicPr>
+            <a:picLocks noChangeAspect="1" noChangeArrowheads="1"/>
+          </p:cNvPicPr>
+          <p:nvPr/>
+        </p:nvPicPr>
+        <p:blipFill rotWithShape="1">
+          <a:blip r:embed="rId2">
+            <a:extLst>
+              <a:ext uri="{28A0092B-C50C-407E-A947-70E740481C1C}">
+                <a14:useLocalDpi xmlns:a14="http://schemas.microsoft.com/office/drawing/2010/main" val="0"/>
+              </a:ext>
+            </a:extLst>
+          </a:blip>
+          <a:srcRect l="48333" t="2500"/>
+          <a:stretch>
+            <a:fillRect/>
+          </a:stretch>
+        </p:blipFill>
+        <p:spPr bwMode="auto">
+          <a:xfrm>
+            <a:off x="0" y="0"/>
+            <a:ext cx="5314950" cy="6686550"/>
+          </a:xfrm>
+          <a:prstGeom prst="rect">
+            <a:avLst/>
+          </a:prstGeom>
+          <a:noFill/>
+          <a:extLst>
+            <a:ext uri="{909E8E84-426E-40DD-AFC4-6F175D3DCCD1}">
+              <a14:hiddenFill xmlns:a14="http://schemas.microsoft.com/office/drawing/2010/main">
+                <a:solidFill>
+                  <a:srgbClr val="FFFFFF"/>
+                </a:solidFill>
+              </a14:hiddenFill>
+            </a:ext>
+          </a:extLst>
+        </p:spPr>
+      </p:pic>
+      <p:pic>
+        <p:nvPicPr>
+          <p:cNvPr id="3" name="Image 2" descr="Une image contenant Pièce auto, outil, machine, rotor&#10;&#10;Le contenu généré par l’IA peut être incorrect.">
+            <a:extLst>
+              <a:ext uri="{FF2B5EF4-FFF2-40B4-BE49-F238E27FC236}">
+                <a16:creationId xmlns:a16="http://schemas.microsoft.com/office/drawing/2014/main" id="{7708C046-C085-0C31-13F5-7493EDC787B7}"/>
+              </a:ext>
+            </a:extLst>
+          </p:cNvPr>
+          <p:cNvPicPr>
+            <a:picLocks noChangeAspect="1"/>
+          </p:cNvPicPr>
+          <p:nvPr/>
+        </p:nvPicPr>
+        <p:blipFill>
+          <a:blip r:embed="rId3">
+            <a:extLst>
+              <a:ext uri="{28A0092B-C50C-407E-A947-70E740481C1C}">
+                <a14:useLocalDpi xmlns:a14="http://schemas.microsoft.com/office/drawing/2010/main" val="0"/>
+              </a:ext>
+            </a:extLst>
+          </a:blip>
+          <a:srcRect t="15023" b="8506"/>
+          <a:stretch>
+            <a:fillRect/>
+          </a:stretch>
+        </p:blipFill>
+        <p:spPr>
+          <a:xfrm>
+            <a:off x="6555133" y="491249"/>
+            <a:ext cx="5149281" cy="5244388"/>
+          </a:xfrm>
+          <a:prstGeom prst="rect">
+            <a:avLst/>
+          </a:prstGeom>
+        </p:spPr>
+      </p:pic>
+      <p:sp>
+        <p:nvSpPr>
+          <p:cNvPr id="4" name="Rectangle 3">
+            <a:extLst>
+              <a:ext uri="{FF2B5EF4-FFF2-40B4-BE49-F238E27FC236}">
+                <a16:creationId xmlns:a16="http://schemas.microsoft.com/office/drawing/2014/main" id="{7BAC2B95-C18C-C9DE-0B86-113B24B7BA56}"/>
+              </a:ext>
+            </a:extLst>
+          </p:cNvPr>
+          <p:cNvSpPr/>
+          <p:nvPr/>
+        </p:nvSpPr>
+        <p:spPr>
+          <a:xfrm>
+            <a:off x="6366254" y="4175481"/>
+            <a:ext cx="975360" cy="505460"/>
+          </a:xfrm>
+          <a:prstGeom prst="rect">
+            <a:avLst/>
+          </a:prstGeom>
+        </p:spPr>
+        <p:style>
+          <a:lnRef idx="2">
+            <a:schemeClr val="accent1">
+              <a:shade val="15000"/>
+            </a:schemeClr>
+          </a:lnRef>
+          <a:fillRef idx="1">
+            <a:schemeClr val="accent1"/>
+          </a:fillRef>
+          <a:effectRef idx="0">
+            <a:schemeClr val="accent1"/>
+          </a:effectRef>
+          <a:fontRef idx="minor">
+            <a:schemeClr val="lt1"/>
+          </a:fontRef>
+        </p:style>
+        <p:txBody>
+          <a:bodyPr rtlCol="0" anchor="ctr"/>
+          <a:lstStyle/>
+          <a:p>
+            <a:pPr algn="ctr"/>
+            <a:r>
+              <a:rPr lang="fr-FR" dirty="0" err="1"/>
+              <a:t>Ph_A</a:t>
+            </a:r>
+            <a:endParaRPr lang="fr-FR" dirty="0"/>
+          </a:p>
+        </p:txBody>
+      </p:sp>
+      <p:sp>
+        <p:nvSpPr>
+          <p:cNvPr id="5" name="Rectangle 4">
+            <a:extLst>
+              <a:ext uri="{FF2B5EF4-FFF2-40B4-BE49-F238E27FC236}">
+                <a16:creationId xmlns:a16="http://schemas.microsoft.com/office/drawing/2014/main" id="{2AD7FB1E-4001-6D10-282C-815F0AC122D0}"/>
+              </a:ext>
+            </a:extLst>
+          </p:cNvPr>
+          <p:cNvSpPr/>
+          <p:nvPr/>
+        </p:nvSpPr>
+        <p:spPr>
+          <a:xfrm>
+            <a:off x="7869934" y="4919999"/>
+            <a:ext cx="975360" cy="505460"/>
+          </a:xfrm>
+          <a:prstGeom prst="rect">
+            <a:avLst/>
+          </a:prstGeom>
+        </p:spPr>
+        <p:style>
+          <a:lnRef idx="2">
+            <a:schemeClr val="accent1">
+              <a:shade val="15000"/>
+            </a:schemeClr>
+          </a:lnRef>
+          <a:fillRef idx="1">
+            <a:schemeClr val="accent1"/>
+          </a:fillRef>
+          <a:effectRef idx="0">
+            <a:schemeClr val="accent1"/>
+          </a:effectRef>
+          <a:fontRef idx="minor">
+            <a:schemeClr val="lt1"/>
+          </a:fontRef>
+        </p:style>
+        <p:txBody>
+          <a:bodyPr rtlCol="0" anchor="ctr"/>
+          <a:lstStyle/>
+          <a:p>
+            <a:pPr algn="ctr"/>
+            <a:r>
+              <a:rPr lang="fr-FR" dirty="0" err="1"/>
+              <a:t>Ph_A</a:t>
+            </a:r>
+            <a:r>
+              <a:rPr lang="fr-FR" dirty="0"/>
+              <a:t>’</a:t>
+            </a:r>
+          </a:p>
+        </p:txBody>
+      </p:sp>
+      <p:sp>
+        <p:nvSpPr>
+          <p:cNvPr id="6" name="Rectangle 5">
+            <a:extLst>
+              <a:ext uri="{FF2B5EF4-FFF2-40B4-BE49-F238E27FC236}">
+                <a16:creationId xmlns:a16="http://schemas.microsoft.com/office/drawing/2014/main" id="{947FDB72-A7C5-0DAB-5C3A-B088B99C695F}"/>
+              </a:ext>
+            </a:extLst>
+          </p:cNvPr>
+          <p:cNvSpPr/>
+          <p:nvPr/>
+        </p:nvSpPr>
+        <p:spPr>
+          <a:xfrm>
+            <a:off x="11070336" y="3286481"/>
+            <a:ext cx="975360" cy="505460"/>
+          </a:xfrm>
+          <a:prstGeom prst="rect">
+            <a:avLst/>
+          </a:prstGeom>
+        </p:spPr>
+        <p:style>
+          <a:lnRef idx="2">
+            <a:schemeClr val="accent1">
+              <a:shade val="15000"/>
+            </a:schemeClr>
+          </a:lnRef>
+          <a:fillRef idx="1">
+            <a:schemeClr val="accent1"/>
+          </a:fillRef>
+          <a:effectRef idx="0">
+            <a:schemeClr val="accent1"/>
+          </a:effectRef>
+          <a:fontRef idx="minor">
+            <a:schemeClr val="lt1"/>
+          </a:fontRef>
+        </p:style>
+        <p:txBody>
+          <a:bodyPr rtlCol="0" anchor="ctr"/>
+          <a:lstStyle/>
+          <a:p>
+            <a:pPr algn="ctr"/>
+            <a:r>
+              <a:rPr lang="fr-FR" dirty="0" err="1"/>
+              <a:t>Ph_B</a:t>
+            </a:r>
+            <a:r>
+              <a:rPr lang="fr-FR" dirty="0"/>
+              <a:t>’</a:t>
+            </a:r>
+          </a:p>
+        </p:txBody>
+      </p:sp>
+      <p:sp>
+        <p:nvSpPr>
+          <p:cNvPr id="7" name="Rectangle 6">
+            <a:extLst>
+              <a:ext uri="{FF2B5EF4-FFF2-40B4-BE49-F238E27FC236}">
+                <a16:creationId xmlns:a16="http://schemas.microsoft.com/office/drawing/2014/main" id="{484E676E-B9FD-6AE9-1B86-EB48CD76F787}"/>
+              </a:ext>
+            </a:extLst>
+          </p:cNvPr>
+          <p:cNvSpPr/>
+          <p:nvPr/>
+        </p:nvSpPr>
+        <p:spPr>
+          <a:xfrm>
+            <a:off x="9383776" y="474384"/>
+            <a:ext cx="975360" cy="505460"/>
+          </a:xfrm>
+          <a:prstGeom prst="rect">
+            <a:avLst/>
+          </a:prstGeom>
+        </p:spPr>
+        <p:style>
+          <a:lnRef idx="2">
+            <a:schemeClr val="accent1">
+              <a:shade val="15000"/>
+            </a:schemeClr>
+          </a:lnRef>
+          <a:fillRef idx="1">
+            <a:schemeClr val="accent1"/>
+          </a:fillRef>
+          <a:effectRef idx="0">
+            <a:schemeClr val="accent1"/>
+          </a:effectRef>
+          <a:fontRef idx="minor">
+            <a:schemeClr val="lt1"/>
+          </a:fontRef>
+        </p:style>
+        <p:txBody>
+          <a:bodyPr rtlCol="0" anchor="ctr"/>
+          <a:lstStyle/>
+          <a:p>
+            <a:pPr algn="ctr"/>
+            <a:r>
+              <a:rPr lang="fr-FR" dirty="0" err="1"/>
+              <a:t>Ph_C</a:t>
+            </a:r>
+            <a:r>
+              <a:rPr lang="fr-FR" dirty="0"/>
+              <a:t>’</a:t>
+            </a:r>
+          </a:p>
+        </p:txBody>
+      </p:sp>
+      <p:sp>
+        <p:nvSpPr>
+          <p:cNvPr id="8" name="Rectangle 7">
+            <a:extLst>
+              <a:ext uri="{FF2B5EF4-FFF2-40B4-BE49-F238E27FC236}">
+                <a16:creationId xmlns:a16="http://schemas.microsoft.com/office/drawing/2014/main" id="{D180FB28-FFA7-9647-A00E-3A7118B40481}"/>
+              </a:ext>
+            </a:extLst>
+          </p:cNvPr>
+          <p:cNvSpPr/>
+          <p:nvPr/>
+        </p:nvSpPr>
+        <p:spPr>
+          <a:xfrm>
+            <a:off x="10729054" y="1300201"/>
+            <a:ext cx="975360" cy="505460"/>
+          </a:xfrm>
+          <a:prstGeom prst="rect">
+            <a:avLst/>
+          </a:prstGeom>
+        </p:spPr>
+        <p:style>
+          <a:lnRef idx="2">
+            <a:schemeClr val="accent1">
+              <a:shade val="15000"/>
+            </a:schemeClr>
+          </a:lnRef>
+          <a:fillRef idx="1">
+            <a:schemeClr val="accent1"/>
+          </a:fillRef>
+          <a:effectRef idx="0">
+            <a:schemeClr val="accent1"/>
+          </a:effectRef>
+          <a:fontRef idx="minor">
+            <a:schemeClr val="lt1"/>
+          </a:fontRef>
+        </p:style>
+        <p:txBody>
+          <a:bodyPr rtlCol="0" anchor="ctr"/>
+          <a:lstStyle/>
+          <a:p>
+            <a:pPr algn="ctr"/>
+            <a:r>
+              <a:rPr lang="fr-FR" dirty="0" err="1"/>
+              <a:t>Ph_C</a:t>
+            </a:r>
+            <a:endParaRPr lang="fr-FR" dirty="0"/>
+          </a:p>
+        </p:txBody>
+      </p:sp>
+      <p:sp>
+        <p:nvSpPr>
+          <p:cNvPr id="9" name="Rectangle 8">
+            <a:extLst>
+              <a:ext uri="{FF2B5EF4-FFF2-40B4-BE49-F238E27FC236}">
+                <a16:creationId xmlns:a16="http://schemas.microsoft.com/office/drawing/2014/main" id="{10FDB4D9-B049-AC8F-13B2-9FE3CAB98C1E}"/>
+              </a:ext>
+            </a:extLst>
+          </p:cNvPr>
+          <p:cNvSpPr/>
+          <p:nvPr/>
+        </p:nvSpPr>
+        <p:spPr>
+          <a:xfrm>
+            <a:off x="10576656" y="4200881"/>
+            <a:ext cx="975360" cy="505460"/>
+          </a:xfrm>
+          <a:prstGeom prst="rect">
+            <a:avLst/>
+          </a:prstGeom>
+        </p:spPr>
+        <p:style>
+          <a:lnRef idx="2">
+            <a:schemeClr val="accent1">
+              <a:shade val="15000"/>
+            </a:schemeClr>
+          </a:lnRef>
+          <a:fillRef idx="1">
+            <a:schemeClr val="accent1"/>
+          </a:fillRef>
+          <a:effectRef idx="0">
+            <a:schemeClr val="accent1"/>
+          </a:effectRef>
+          <a:fontRef idx="minor">
+            <a:schemeClr val="lt1"/>
+          </a:fontRef>
+        </p:style>
+        <p:txBody>
+          <a:bodyPr rtlCol="0" anchor="ctr"/>
+          <a:lstStyle/>
+          <a:p>
+            <a:pPr algn="ctr"/>
+            <a:r>
+              <a:rPr lang="fr-FR" dirty="0" err="1"/>
+              <a:t>Ph_B</a:t>
+            </a:r>
+            <a:endParaRPr lang="fr-FR" dirty="0"/>
+          </a:p>
+        </p:txBody>
+      </p:sp>
+      <p:cxnSp>
+        <p:nvCxnSpPr>
+          <p:cNvPr id="10" name="Connecteur droit 9">
+            <a:extLst>
+              <a:ext uri="{FF2B5EF4-FFF2-40B4-BE49-F238E27FC236}">
+                <a16:creationId xmlns:a16="http://schemas.microsoft.com/office/drawing/2014/main" id="{0B7E54DC-7FC1-CEFC-DF5E-B2FE69C59EE2}"/>
+              </a:ext>
+            </a:extLst>
+          </p:cNvPr>
+          <p:cNvCxnSpPr>
+            <a:cxnSpLocks/>
+          </p:cNvCxnSpPr>
+          <p:nvPr/>
+        </p:nvCxnSpPr>
+        <p:spPr>
+          <a:xfrm flipV="1">
+            <a:off x="8642094" y="3343275"/>
+            <a:ext cx="2086960" cy="1363066"/>
+          </a:xfrm>
+          <a:prstGeom prst="line">
+            <a:avLst/>
+          </a:prstGeom>
+          <a:ln w="57150">
+            <a:solidFill>
+              <a:srgbClr val="FF0000"/>
+            </a:solidFill>
+          </a:ln>
+        </p:spPr>
+        <p:style>
+          <a:lnRef idx="2">
+            <a:schemeClr val="accent1"/>
+          </a:lnRef>
+          <a:fillRef idx="0">
+            <a:schemeClr val="accent1"/>
+          </a:fillRef>
+          <a:effectRef idx="1">
+            <a:schemeClr val="accent1"/>
+          </a:effectRef>
+          <a:fontRef idx="minor">
+            <a:schemeClr val="tx1"/>
+          </a:fontRef>
+        </p:style>
+      </p:cxnSp>
+      <p:cxnSp>
+        <p:nvCxnSpPr>
+          <p:cNvPr id="11" name="Connecteur droit 10">
+            <a:extLst>
+              <a:ext uri="{FF2B5EF4-FFF2-40B4-BE49-F238E27FC236}">
+                <a16:creationId xmlns:a16="http://schemas.microsoft.com/office/drawing/2014/main" id="{51437654-3580-C12B-0A34-799314A6E679}"/>
+              </a:ext>
+            </a:extLst>
+          </p:cNvPr>
+          <p:cNvCxnSpPr>
+            <a:cxnSpLocks/>
+          </p:cNvCxnSpPr>
+          <p:nvPr/>
+        </p:nvCxnSpPr>
+        <p:spPr>
+          <a:xfrm>
+            <a:off x="9672179" y="1381481"/>
+            <a:ext cx="1056875" cy="1905000"/>
+          </a:xfrm>
+          <a:prstGeom prst="line">
+            <a:avLst/>
+          </a:prstGeom>
+          <a:ln w="57150">
+            <a:solidFill>
+              <a:srgbClr val="FF0000"/>
+            </a:solidFill>
+          </a:ln>
+        </p:spPr>
+        <p:style>
+          <a:lnRef idx="2">
+            <a:schemeClr val="accent1"/>
+          </a:lnRef>
+          <a:fillRef idx="0">
+            <a:schemeClr val="accent1"/>
+          </a:fillRef>
+          <a:effectRef idx="1">
+            <a:schemeClr val="accent1"/>
+          </a:effectRef>
+          <a:fontRef idx="minor">
+            <a:schemeClr val="tx1"/>
+          </a:fontRef>
+        </p:style>
+      </p:cxnSp>
+      <p:sp>
+        <p:nvSpPr>
+          <p:cNvPr id="13" name="Rectangle 12">
+            <a:extLst>
+              <a:ext uri="{FF2B5EF4-FFF2-40B4-BE49-F238E27FC236}">
+                <a16:creationId xmlns:a16="http://schemas.microsoft.com/office/drawing/2014/main" id="{3A4983CE-273A-B036-6D65-EE857312AD55}"/>
+              </a:ext>
+            </a:extLst>
+          </p:cNvPr>
+          <p:cNvSpPr/>
+          <p:nvPr/>
+        </p:nvSpPr>
+        <p:spPr>
+          <a:xfrm>
+            <a:off x="2743199" y="171450"/>
+            <a:ext cx="651891" cy="186436"/>
+          </a:xfrm>
+          <a:prstGeom prst="rect">
+            <a:avLst/>
+          </a:prstGeom>
+        </p:spPr>
+        <p:style>
+          <a:lnRef idx="2">
+            <a:schemeClr val="accent1">
+              <a:shade val="15000"/>
+            </a:schemeClr>
+          </a:lnRef>
+          <a:fillRef idx="1">
+            <a:schemeClr val="accent1"/>
+          </a:fillRef>
+          <a:effectRef idx="0">
+            <a:schemeClr val="accent1"/>
+          </a:effectRef>
+          <a:fontRef idx="minor">
+            <a:schemeClr val="lt1"/>
+          </a:fontRef>
+        </p:style>
+        <p:txBody>
+          <a:bodyPr rtlCol="0" anchor="ctr"/>
+          <a:lstStyle/>
+          <a:p>
+            <a:pPr algn="ctr"/>
+            <a:r>
+              <a:rPr lang="fr-FR" sz="1200" dirty="0" err="1"/>
+              <a:t>Ph_A</a:t>
+            </a:r>
+            <a:endParaRPr lang="fr-FR" sz="1200" dirty="0"/>
+          </a:p>
+        </p:txBody>
+      </p:sp>
+      <p:sp>
+        <p:nvSpPr>
+          <p:cNvPr id="14" name="Rectangle 13">
+            <a:extLst>
+              <a:ext uri="{FF2B5EF4-FFF2-40B4-BE49-F238E27FC236}">
+                <a16:creationId xmlns:a16="http://schemas.microsoft.com/office/drawing/2014/main" id="{48F429EC-322B-8D15-2220-F7BB27319FC7}"/>
+              </a:ext>
+            </a:extLst>
+          </p:cNvPr>
+          <p:cNvSpPr/>
+          <p:nvPr/>
+        </p:nvSpPr>
+        <p:spPr>
+          <a:xfrm>
+            <a:off x="2697196" y="1113765"/>
+            <a:ext cx="651891" cy="186436"/>
+          </a:xfrm>
+          <a:prstGeom prst="rect">
+            <a:avLst/>
+          </a:prstGeom>
+        </p:spPr>
+        <p:style>
+          <a:lnRef idx="2">
+            <a:schemeClr val="accent1">
+              <a:shade val="15000"/>
+            </a:schemeClr>
+          </a:lnRef>
+          <a:fillRef idx="1">
+            <a:schemeClr val="accent1"/>
+          </a:fillRef>
+          <a:effectRef idx="0">
+            <a:schemeClr val="accent1"/>
+          </a:effectRef>
+          <a:fontRef idx="minor">
+            <a:schemeClr val="lt1"/>
+          </a:fontRef>
+        </p:style>
+        <p:txBody>
+          <a:bodyPr rtlCol="0" anchor="ctr"/>
+          <a:lstStyle/>
+          <a:p>
+            <a:pPr algn="ctr"/>
+            <a:r>
+              <a:rPr lang="fr-FR" sz="1200" dirty="0" err="1"/>
+              <a:t>Ph_A</a:t>
+            </a:r>
+            <a:r>
+              <a:rPr lang="fr-FR" sz="1200" dirty="0"/>
+              <a:t>’</a:t>
+            </a:r>
+          </a:p>
+        </p:txBody>
+      </p:sp>
+      <p:sp>
+        <p:nvSpPr>
+          <p:cNvPr id="15" name="Rectangle 14">
+            <a:extLst>
+              <a:ext uri="{FF2B5EF4-FFF2-40B4-BE49-F238E27FC236}">
+                <a16:creationId xmlns:a16="http://schemas.microsoft.com/office/drawing/2014/main" id="{D7741700-8596-BB1B-0B7B-69971C08E7B4}"/>
+              </a:ext>
+            </a:extLst>
+          </p:cNvPr>
+          <p:cNvSpPr/>
+          <p:nvPr/>
+        </p:nvSpPr>
+        <p:spPr>
+          <a:xfrm>
+            <a:off x="3754371" y="2308810"/>
+            <a:ext cx="651891" cy="186436"/>
+          </a:xfrm>
+          <a:prstGeom prst="rect">
+            <a:avLst/>
+          </a:prstGeom>
+        </p:spPr>
+        <p:style>
+          <a:lnRef idx="2">
+            <a:schemeClr val="accent1">
+              <a:shade val="15000"/>
+            </a:schemeClr>
+          </a:lnRef>
+          <a:fillRef idx="1">
+            <a:schemeClr val="accent1"/>
+          </a:fillRef>
+          <a:effectRef idx="0">
+            <a:schemeClr val="accent1"/>
+          </a:effectRef>
+          <a:fontRef idx="minor">
+            <a:schemeClr val="lt1"/>
+          </a:fontRef>
+        </p:style>
+        <p:txBody>
+          <a:bodyPr rtlCol="0" anchor="ctr"/>
+          <a:lstStyle/>
+          <a:p>
+            <a:pPr algn="ctr"/>
+            <a:r>
+              <a:rPr lang="fr-FR" sz="1200" dirty="0" err="1"/>
+              <a:t>Ph_B</a:t>
+            </a:r>
+            <a:endParaRPr lang="fr-FR" sz="1200" dirty="0"/>
+          </a:p>
+        </p:txBody>
+      </p:sp>
+      <p:sp>
+        <p:nvSpPr>
+          <p:cNvPr id="16" name="Rectangle 15">
+            <a:extLst>
+              <a:ext uri="{FF2B5EF4-FFF2-40B4-BE49-F238E27FC236}">
+                <a16:creationId xmlns:a16="http://schemas.microsoft.com/office/drawing/2014/main" id="{71F1FAAC-8F37-0A1D-1479-7D3AE3C93EC3}"/>
+              </a:ext>
+            </a:extLst>
+          </p:cNvPr>
+          <p:cNvSpPr/>
+          <p:nvPr/>
+        </p:nvSpPr>
+        <p:spPr>
+          <a:xfrm>
+            <a:off x="2975044" y="1514069"/>
+            <a:ext cx="651891" cy="186436"/>
+          </a:xfrm>
+          <a:prstGeom prst="rect">
+            <a:avLst/>
+          </a:prstGeom>
+        </p:spPr>
+        <p:style>
+          <a:lnRef idx="2">
+            <a:schemeClr val="accent1">
+              <a:shade val="15000"/>
+            </a:schemeClr>
+          </a:lnRef>
+          <a:fillRef idx="1">
+            <a:schemeClr val="accent1"/>
+          </a:fillRef>
+          <a:effectRef idx="0">
+            <a:schemeClr val="accent1"/>
+          </a:effectRef>
+          <a:fontRef idx="minor">
+            <a:schemeClr val="lt1"/>
+          </a:fontRef>
+        </p:style>
+        <p:txBody>
+          <a:bodyPr rtlCol="0" anchor="ctr"/>
+          <a:lstStyle/>
+          <a:p>
+            <a:pPr algn="ctr"/>
+            <a:r>
+              <a:rPr lang="fr-FR" sz="1200" dirty="0" err="1"/>
+              <a:t>Ph_B</a:t>
+            </a:r>
+            <a:r>
+              <a:rPr lang="fr-FR" sz="1200" dirty="0"/>
+              <a:t>’</a:t>
+            </a:r>
+          </a:p>
+        </p:txBody>
+      </p:sp>
+      <p:sp>
+        <p:nvSpPr>
+          <p:cNvPr id="17" name="Rectangle 16">
+            <a:extLst>
+              <a:ext uri="{FF2B5EF4-FFF2-40B4-BE49-F238E27FC236}">
+                <a16:creationId xmlns:a16="http://schemas.microsoft.com/office/drawing/2014/main" id="{35AEC655-044A-CE26-E0B4-9BE3956BF826}"/>
+              </a:ext>
+            </a:extLst>
+          </p:cNvPr>
+          <p:cNvSpPr/>
+          <p:nvPr/>
+        </p:nvSpPr>
+        <p:spPr>
+          <a:xfrm>
+            <a:off x="811055" y="2308810"/>
+            <a:ext cx="651891" cy="186436"/>
+          </a:xfrm>
+          <a:prstGeom prst="rect">
+            <a:avLst/>
+          </a:prstGeom>
+        </p:spPr>
+        <p:style>
+          <a:lnRef idx="2">
+            <a:schemeClr val="accent1">
+              <a:shade val="15000"/>
+            </a:schemeClr>
+          </a:lnRef>
+          <a:fillRef idx="1">
+            <a:schemeClr val="accent1"/>
+          </a:fillRef>
+          <a:effectRef idx="0">
+            <a:schemeClr val="accent1"/>
+          </a:effectRef>
+          <a:fontRef idx="minor">
+            <a:schemeClr val="lt1"/>
+          </a:fontRef>
+        </p:style>
+        <p:txBody>
+          <a:bodyPr rtlCol="0" anchor="ctr"/>
+          <a:lstStyle/>
+          <a:p>
+            <a:pPr algn="ctr"/>
+            <a:r>
+              <a:rPr lang="fr-FR" sz="1200" dirty="0" err="1"/>
+              <a:t>Ph_C</a:t>
+            </a:r>
+            <a:endParaRPr lang="fr-FR" sz="1200" dirty="0"/>
+          </a:p>
+        </p:txBody>
+      </p:sp>
+      <p:sp>
+        <p:nvSpPr>
+          <p:cNvPr id="18" name="Rectangle 17">
+            <a:extLst>
+              <a:ext uri="{FF2B5EF4-FFF2-40B4-BE49-F238E27FC236}">
+                <a16:creationId xmlns:a16="http://schemas.microsoft.com/office/drawing/2014/main" id="{FB330E74-8226-9564-6864-EC5FDAF613AD}"/>
+              </a:ext>
+            </a:extLst>
+          </p:cNvPr>
+          <p:cNvSpPr/>
+          <p:nvPr/>
+        </p:nvSpPr>
+        <p:spPr>
+          <a:xfrm>
+            <a:off x="1597794" y="1504646"/>
+            <a:ext cx="651891" cy="186436"/>
+          </a:xfrm>
+          <a:prstGeom prst="rect">
+            <a:avLst/>
+          </a:prstGeom>
+        </p:spPr>
+        <p:style>
+          <a:lnRef idx="2">
+            <a:schemeClr val="accent1">
+              <a:shade val="15000"/>
+            </a:schemeClr>
+          </a:lnRef>
+          <a:fillRef idx="1">
+            <a:schemeClr val="accent1"/>
+          </a:fillRef>
+          <a:effectRef idx="0">
+            <a:schemeClr val="accent1"/>
+          </a:effectRef>
+          <a:fontRef idx="minor">
+            <a:schemeClr val="lt1"/>
+          </a:fontRef>
+        </p:style>
+        <p:txBody>
+          <a:bodyPr rtlCol="0" anchor="ctr"/>
+          <a:lstStyle/>
+          <a:p>
+            <a:pPr algn="ctr"/>
+            <a:r>
+              <a:rPr lang="fr-FR" sz="1200" dirty="0" err="1"/>
+              <a:t>Ph_C</a:t>
+            </a:r>
+            <a:r>
+              <a:rPr lang="fr-FR" sz="1200" dirty="0"/>
+              <a:t>’</a:t>
+            </a:r>
+          </a:p>
+        </p:txBody>
+      </p:sp>
+    </p:spTree>
+    <p:extLst>
+      <p:ext uri="{BB962C8B-B14F-4D97-AF65-F5344CB8AC3E}">
+        <p14:creationId xmlns:p14="http://schemas.microsoft.com/office/powerpoint/2010/main" val="2727794585"/>
+      </p:ext>
+    </p:extLst>
+  </p:cSld>
+  <p:clrMapOvr>
+    <a:masterClrMapping/>
+  </p:clrMapOvr>
+</p:sld>
+</file>
+
 <file path=ppt/theme/theme1.xml><?xml version="1.0" encoding="utf-8"?>
 <a:theme xmlns:a="http://schemas.openxmlformats.org/drawingml/2006/main" name="Thème Office">
   <a:themeElements>

</xml_diff>